<commit_message>
add vinrobotics and update gaode logo
</commit_message>
<xml_diff>
--- a/pic/adoption_logos/adoption.pptx
+++ b/pic/adoption_logos/adoption.pptx
@@ -259,7 +259,7 @@
           <a:p>
             <a:fld id="{8E119A9B-EC2C-F046-AB6F-3B9C9A28D3EB}" type="datetimeFigureOut">
               <a:rPr kumimoji="1" lang="zh-CN" altLang="en-US" smtClean="0"/>
-              <a:t>2026/5/24</a:t>
+              <a:t>2026/6/1</a:t>
             </a:fld>
             <a:endParaRPr kumimoji="1" lang="zh-CN" altLang="en-US"/>
           </a:p>
@@ -457,7 +457,7 @@
           <a:p>
             <a:fld id="{8E119A9B-EC2C-F046-AB6F-3B9C9A28D3EB}" type="datetimeFigureOut">
               <a:rPr kumimoji="1" lang="zh-CN" altLang="en-US" smtClean="0"/>
-              <a:t>2026/5/24</a:t>
+              <a:t>2026/6/1</a:t>
             </a:fld>
             <a:endParaRPr kumimoji="1" lang="zh-CN" altLang="en-US"/>
           </a:p>
@@ -665,7 +665,7 @@
           <a:p>
             <a:fld id="{8E119A9B-EC2C-F046-AB6F-3B9C9A28D3EB}" type="datetimeFigureOut">
               <a:rPr kumimoji="1" lang="zh-CN" altLang="en-US" smtClean="0"/>
-              <a:t>2026/5/24</a:t>
+              <a:t>2026/6/1</a:t>
             </a:fld>
             <a:endParaRPr kumimoji="1" lang="zh-CN" altLang="en-US"/>
           </a:p>
@@ -863,7 +863,7 @@
           <a:p>
             <a:fld id="{8E119A9B-EC2C-F046-AB6F-3B9C9A28D3EB}" type="datetimeFigureOut">
               <a:rPr kumimoji="1" lang="zh-CN" altLang="en-US" smtClean="0"/>
-              <a:t>2026/5/24</a:t>
+              <a:t>2026/6/1</a:t>
             </a:fld>
             <a:endParaRPr kumimoji="1" lang="zh-CN" altLang="en-US"/>
           </a:p>
@@ -1138,7 +1138,7 @@
           <a:p>
             <a:fld id="{8E119A9B-EC2C-F046-AB6F-3B9C9A28D3EB}" type="datetimeFigureOut">
               <a:rPr kumimoji="1" lang="zh-CN" altLang="en-US" smtClean="0"/>
-              <a:t>2026/5/24</a:t>
+              <a:t>2026/6/1</a:t>
             </a:fld>
             <a:endParaRPr kumimoji="1" lang="zh-CN" altLang="en-US"/>
           </a:p>
@@ -1403,7 +1403,7 @@
           <a:p>
             <a:fld id="{8E119A9B-EC2C-F046-AB6F-3B9C9A28D3EB}" type="datetimeFigureOut">
               <a:rPr kumimoji="1" lang="zh-CN" altLang="en-US" smtClean="0"/>
-              <a:t>2026/5/24</a:t>
+              <a:t>2026/6/1</a:t>
             </a:fld>
             <a:endParaRPr kumimoji="1" lang="zh-CN" altLang="en-US"/>
           </a:p>
@@ -1815,7 +1815,7 @@
           <a:p>
             <a:fld id="{8E119A9B-EC2C-F046-AB6F-3B9C9A28D3EB}" type="datetimeFigureOut">
               <a:rPr kumimoji="1" lang="zh-CN" altLang="en-US" smtClean="0"/>
-              <a:t>2026/5/24</a:t>
+              <a:t>2026/6/1</a:t>
             </a:fld>
             <a:endParaRPr kumimoji="1" lang="zh-CN" altLang="en-US"/>
           </a:p>
@@ -1956,7 +1956,7 @@
           <a:p>
             <a:fld id="{8E119A9B-EC2C-F046-AB6F-3B9C9A28D3EB}" type="datetimeFigureOut">
               <a:rPr kumimoji="1" lang="zh-CN" altLang="en-US" smtClean="0"/>
-              <a:t>2026/5/24</a:t>
+              <a:t>2026/6/1</a:t>
             </a:fld>
             <a:endParaRPr kumimoji="1" lang="zh-CN" altLang="en-US"/>
           </a:p>
@@ -2069,7 +2069,7 @@
           <a:p>
             <a:fld id="{8E119A9B-EC2C-F046-AB6F-3B9C9A28D3EB}" type="datetimeFigureOut">
               <a:rPr kumimoji="1" lang="zh-CN" altLang="en-US" smtClean="0"/>
-              <a:t>2026/5/24</a:t>
+              <a:t>2026/6/1</a:t>
             </a:fld>
             <a:endParaRPr kumimoji="1" lang="zh-CN" altLang="en-US"/>
           </a:p>
@@ -2380,7 +2380,7 @@
           <a:p>
             <a:fld id="{8E119A9B-EC2C-F046-AB6F-3B9C9A28D3EB}" type="datetimeFigureOut">
               <a:rPr kumimoji="1" lang="zh-CN" altLang="en-US" smtClean="0"/>
-              <a:t>2026/5/24</a:t>
+              <a:t>2026/6/1</a:t>
             </a:fld>
             <a:endParaRPr kumimoji="1" lang="zh-CN" altLang="en-US"/>
           </a:p>
@@ -2668,7 +2668,7 @@
           <a:p>
             <a:fld id="{8E119A9B-EC2C-F046-AB6F-3B9C9A28D3EB}" type="datetimeFigureOut">
               <a:rPr kumimoji="1" lang="zh-CN" altLang="en-US" smtClean="0"/>
-              <a:t>2026/5/24</a:t>
+              <a:t>2026/6/1</a:t>
             </a:fld>
             <a:endParaRPr kumimoji="1" lang="zh-CN" altLang="en-US"/>
           </a:p>
@@ -2909,7 +2909,7 @@
           <a:p>
             <a:fld id="{8E119A9B-EC2C-F046-AB6F-3B9C9A28D3EB}" type="datetimeFigureOut">
               <a:rPr kumimoji="1" lang="zh-CN" altLang="en-US" smtClean="0"/>
-              <a:t>2026/5/24</a:t>
+              <a:t>2026/6/1</a:t>
             </a:fld>
             <a:endParaRPr kumimoji="1" lang="zh-CN" altLang="en-US"/>
           </a:p>
@@ -3755,10 +3755,57 @@
       </p:pic>
       <p:pic>
         <p:nvPicPr>
-          <p:cNvPr id="12" name="Picture 2" descr="AMap Global - APK Download for Android | Aptoide">
-            <a:extLst>
-              <a:ext uri="{FF2B5EF4-FFF2-40B4-BE49-F238E27FC236}">
-                <a16:creationId xmlns:a16="http://schemas.microsoft.com/office/drawing/2014/main" id="{66EF2695-0CB7-B8B0-9031-54F6CEEFC9F4}"/>
+          <p:cNvPr id="8" name="Picture 2" descr="高德地图logo">
+            <a:extLst>
+              <a:ext uri="{FF2B5EF4-FFF2-40B4-BE49-F238E27FC236}">
+                <a16:creationId xmlns:a16="http://schemas.microsoft.com/office/drawing/2014/main" id="{B7B45763-A296-20E5-096F-34F16D17E05F}"/>
+              </a:ext>
+            </a:extLst>
+          </p:cNvPr>
+          <p:cNvPicPr>
+            <a:picLocks noChangeAspect="1" noChangeArrowheads="1"/>
+          </p:cNvPicPr>
+          <p:nvPr/>
+        </p:nvPicPr>
+        <p:blipFill rotWithShape="1">
+          <a:blip r:embed="rId15">
+            <a:extLst>
+              <a:ext uri="{28A0092B-C50C-407E-A947-70E740481C1C}">
+                <a14:useLocalDpi xmlns:a14="http://schemas.microsoft.com/office/drawing/2010/main" val="0"/>
+              </a:ext>
+            </a:extLst>
+          </a:blip>
+          <a:srcRect l="2084" t="12648" r="8100" b="16755"/>
+          <a:stretch>
+            <a:fillRect/>
+          </a:stretch>
+        </p:blipFill>
+        <p:spPr bwMode="auto">
+          <a:xfrm>
+            <a:off x="324266" y="2923349"/>
+            <a:ext cx="1848368" cy="468000"/>
+          </a:xfrm>
+          <a:prstGeom prst="rect">
+            <a:avLst/>
+          </a:prstGeom>
+          <a:noFill/>
+          <a:extLst>
+            <a:ext uri="{909E8E84-426E-40DD-AFC4-6F175D3DCCD1}">
+              <a14:hiddenFill xmlns:a14="http://schemas.microsoft.com/office/drawing/2010/main">
+                <a:solidFill>
+                  <a:srgbClr val="FFFFFF"/>
+                </a:solidFill>
+              </a14:hiddenFill>
+            </a:ext>
+          </a:extLst>
+        </p:spPr>
+      </p:pic>
+      <p:pic>
+        <p:nvPicPr>
+          <p:cNvPr id="1028" name="Picture 4" descr="About - Vingroup Company">
+            <a:extLst>
+              <a:ext uri="{FF2B5EF4-FFF2-40B4-BE49-F238E27FC236}">
+                <a16:creationId xmlns:a16="http://schemas.microsoft.com/office/drawing/2014/main" id="{0A3329B4-47E5-2254-71B7-56FB36300D4F}"/>
               </a:ext>
             </a:extLst>
           </p:cNvPr>
@@ -3768,7 +3815,7 @@
           <p:nvPr/>
         </p:nvPicPr>
         <p:blipFill>
-          <a:blip r:embed="rId15">
+          <a:blip r:embed="rId16">
             <a:extLst>
               <a:ext uri="{28A0092B-C50C-407E-A947-70E740481C1C}">
                 <a14:useLocalDpi xmlns:a14="http://schemas.microsoft.com/office/drawing/2010/main" val="0"/>
@@ -3782,8 +3829,8 @@
         </p:blipFill>
         <p:spPr bwMode="auto">
           <a:xfrm>
-            <a:off x="5240679" y="2983784"/>
-            <a:ext cx="503999" cy="503999"/>
+            <a:off x="2723343" y="2923349"/>
+            <a:ext cx="3167163" cy="468000"/>
           </a:xfrm>
           <a:prstGeom prst="rect">
             <a:avLst/>

</xml_diff>

<commit_message>
add astribot, vbot, spirit AI logo
</commit_message>
<xml_diff>
--- a/pic/adoption_logos/adoption.pptx
+++ b/pic/adoption_logos/adoption.pptx
@@ -259,7 +259,7 @@
           <a:p>
             <a:fld id="{8E119A9B-EC2C-F046-AB6F-3B9C9A28D3EB}" type="datetimeFigureOut">
               <a:rPr kumimoji="1" lang="zh-CN" altLang="en-US" smtClean="0"/>
-              <a:t>2026/6/1</a:t>
+              <a:t>2026/6/17</a:t>
             </a:fld>
             <a:endParaRPr kumimoji="1" lang="zh-CN" altLang="en-US"/>
           </a:p>
@@ -457,7 +457,7 @@
           <a:p>
             <a:fld id="{8E119A9B-EC2C-F046-AB6F-3B9C9A28D3EB}" type="datetimeFigureOut">
               <a:rPr kumimoji="1" lang="zh-CN" altLang="en-US" smtClean="0"/>
-              <a:t>2026/6/1</a:t>
+              <a:t>2026/6/17</a:t>
             </a:fld>
             <a:endParaRPr kumimoji="1" lang="zh-CN" altLang="en-US"/>
           </a:p>
@@ -665,7 +665,7 @@
           <a:p>
             <a:fld id="{8E119A9B-EC2C-F046-AB6F-3B9C9A28D3EB}" type="datetimeFigureOut">
               <a:rPr kumimoji="1" lang="zh-CN" altLang="en-US" smtClean="0"/>
-              <a:t>2026/6/1</a:t>
+              <a:t>2026/6/17</a:t>
             </a:fld>
             <a:endParaRPr kumimoji="1" lang="zh-CN" altLang="en-US"/>
           </a:p>
@@ -863,7 +863,7 @@
           <a:p>
             <a:fld id="{8E119A9B-EC2C-F046-AB6F-3B9C9A28D3EB}" type="datetimeFigureOut">
               <a:rPr kumimoji="1" lang="zh-CN" altLang="en-US" smtClean="0"/>
-              <a:t>2026/6/1</a:t>
+              <a:t>2026/6/17</a:t>
             </a:fld>
             <a:endParaRPr kumimoji="1" lang="zh-CN" altLang="en-US"/>
           </a:p>
@@ -1138,7 +1138,7 @@
           <a:p>
             <a:fld id="{8E119A9B-EC2C-F046-AB6F-3B9C9A28D3EB}" type="datetimeFigureOut">
               <a:rPr kumimoji="1" lang="zh-CN" altLang="en-US" smtClean="0"/>
-              <a:t>2026/6/1</a:t>
+              <a:t>2026/6/17</a:t>
             </a:fld>
             <a:endParaRPr kumimoji="1" lang="zh-CN" altLang="en-US"/>
           </a:p>
@@ -1403,7 +1403,7 @@
           <a:p>
             <a:fld id="{8E119A9B-EC2C-F046-AB6F-3B9C9A28D3EB}" type="datetimeFigureOut">
               <a:rPr kumimoji="1" lang="zh-CN" altLang="en-US" smtClean="0"/>
-              <a:t>2026/6/1</a:t>
+              <a:t>2026/6/17</a:t>
             </a:fld>
             <a:endParaRPr kumimoji="1" lang="zh-CN" altLang="en-US"/>
           </a:p>
@@ -1815,7 +1815,7 @@
           <a:p>
             <a:fld id="{8E119A9B-EC2C-F046-AB6F-3B9C9A28D3EB}" type="datetimeFigureOut">
               <a:rPr kumimoji="1" lang="zh-CN" altLang="en-US" smtClean="0"/>
-              <a:t>2026/6/1</a:t>
+              <a:t>2026/6/17</a:t>
             </a:fld>
             <a:endParaRPr kumimoji="1" lang="zh-CN" altLang="en-US"/>
           </a:p>
@@ -1956,7 +1956,7 @@
           <a:p>
             <a:fld id="{8E119A9B-EC2C-F046-AB6F-3B9C9A28D3EB}" type="datetimeFigureOut">
               <a:rPr kumimoji="1" lang="zh-CN" altLang="en-US" smtClean="0"/>
-              <a:t>2026/6/1</a:t>
+              <a:t>2026/6/17</a:t>
             </a:fld>
             <a:endParaRPr kumimoji="1" lang="zh-CN" altLang="en-US"/>
           </a:p>
@@ -2069,7 +2069,7 @@
           <a:p>
             <a:fld id="{8E119A9B-EC2C-F046-AB6F-3B9C9A28D3EB}" type="datetimeFigureOut">
               <a:rPr kumimoji="1" lang="zh-CN" altLang="en-US" smtClean="0"/>
-              <a:t>2026/6/1</a:t>
+              <a:t>2026/6/17</a:t>
             </a:fld>
             <a:endParaRPr kumimoji="1" lang="zh-CN" altLang="en-US"/>
           </a:p>
@@ -2380,7 +2380,7 @@
           <a:p>
             <a:fld id="{8E119A9B-EC2C-F046-AB6F-3B9C9A28D3EB}" type="datetimeFigureOut">
               <a:rPr kumimoji="1" lang="zh-CN" altLang="en-US" smtClean="0"/>
-              <a:t>2026/6/1</a:t>
+              <a:t>2026/6/17</a:t>
             </a:fld>
             <a:endParaRPr kumimoji="1" lang="zh-CN" altLang="en-US"/>
           </a:p>
@@ -2668,7 +2668,7 @@
           <a:p>
             <a:fld id="{8E119A9B-EC2C-F046-AB6F-3B9C9A28D3EB}" type="datetimeFigureOut">
               <a:rPr kumimoji="1" lang="zh-CN" altLang="en-US" smtClean="0"/>
-              <a:t>2026/6/1</a:t>
+              <a:t>2026/6/17</a:t>
             </a:fld>
             <a:endParaRPr kumimoji="1" lang="zh-CN" altLang="en-US"/>
           </a:p>
@@ -2909,7 +2909,7 @@
           <a:p>
             <a:fld id="{8E119A9B-EC2C-F046-AB6F-3B9C9A28D3EB}" type="datetimeFigureOut">
               <a:rPr kumimoji="1" lang="zh-CN" altLang="en-US" smtClean="0"/>
-              <a:t>2026/6/1</a:t>
+              <a:t>2026/6/17</a:t>
             </a:fld>
             <a:endParaRPr kumimoji="1" lang="zh-CN" altLang="en-US"/>
           </a:p>
@@ -3847,6 +3847,130 @@
           </a:extLst>
         </p:spPr>
       </p:pic>
+      <p:pic>
+        <p:nvPicPr>
+          <p:cNvPr id="12" name="图片 11">
+            <a:extLst>
+              <a:ext uri="{FF2B5EF4-FFF2-40B4-BE49-F238E27FC236}">
+                <a16:creationId xmlns:a16="http://schemas.microsoft.com/office/drawing/2014/main" id="{2A27ED8F-264C-5776-AC9F-B9B3E945E297}"/>
+              </a:ext>
+            </a:extLst>
+          </p:cNvPr>
+          <p:cNvPicPr>
+            <a:picLocks noChangeAspect="1"/>
+          </p:cNvPicPr>
+          <p:nvPr/>
+        </p:nvPicPr>
+        <p:blipFill>
+          <a:blip r:embed="rId17"/>
+          <a:stretch>
+            <a:fillRect/>
+          </a:stretch>
+        </p:blipFill>
+        <p:spPr>
+          <a:xfrm>
+            <a:off x="6333641" y="2923349"/>
+            <a:ext cx="1448000" cy="468000"/>
+          </a:xfrm>
+          <a:prstGeom prst="rect">
+            <a:avLst/>
+          </a:prstGeom>
+        </p:spPr>
+      </p:pic>
+      <p:pic>
+        <p:nvPicPr>
+          <p:cNvPr id="18" name="Picture 4" descr="文档中心">
+            <a:extLst>
+              <a:ext uri="{FF2B5EF4-FFF2-40B4-BE49-F238E27FC236}">
+                <a16:creationId xmlns:a16="http://schemas.microsoft.com/office/drawing/2014/main" id="{95E91AB5-B259-7790-131C-49FEC7A3617F}"/>
+              </a:ext>
+            </a:extLst>
+          </p:cNvPr>
+          <p:cNvPicPr>
+            <a:picLocks noChangeAspect="1" noChangeArrowheads="1"/>
+          </p:cNvPicPr>
+          <p:nvPr/>
+        </p:nvPicPr>
+        <p:blipFill rotWithShape="1">
+          <a:blip r:embed="rId18">
+            <a:extLst>
+              <a:ext uri="{28A0092B-C50C-407E-A947-70E740481C1C}">
+                <a14:useLocalDpi xmlns:a14="http://schemas.microsoft.com/office/drawing/2010/main" val="0"/>
+              </a:ext>
+            </a:extLst>
+          </a:blip>
+          <a:srcRect l="17370" t="25424" r="17197" b="25633"/>
+          <a:stretch>
+            <a:fillRect/>
+          </a:stretch>
+        </p:blipFill>
+        <p:spPr bwMode="auto">
+          <a:xfrm>
+            <a:off x="8167607" y="2923349"/>
+            <a:ext cx="1789707" cy="468000"/>
+          </a:xfrm>
+          <a:prstGeom prst="rect">
+            <a:avLst/>
+          </a:prstGeom>
+          <a:noFill/>
+          <a:extLst>
+            <a:ext uri="{909E8E84-426E-40DD-AFC4-6F175D3DCCD1}">
+              <a14:hiddenFill xmlns:a14="http://schemas.microsoft.com/office/drawing/2010/main">
+                <a:solidFill>
+                  <a:srgbClr val="FFFFFF"/>
+                </a:solidFill>
+              </a14:hiddenFill>
+            </a:ext>
+          </a:extLst>
+        </p:spPr>
+      </p:pic>
+      <p:pic>
+        <p:nvPicPr>
+          <p:cNvPr id="1030" name="Picture 6" descr="Vita Dynamics (Beijing) Technology Co., Ltd._Baiduwiki">
+            <a:extLst>
+              <a:ext uri="{FF2B5EF4-FFF2-40B4-BE49-F238E27FC236}">
+                <a16:creationId xmlns:a16="http://schemas.microsoft.com/office/drawing/2014/main" id="{3C7B266C-8953-1422-4099-4010888B79B7}"/>
+              </a:ext>
+            </a:extLst>
+          </p:cNvPr>
+          <p:cNvPicPr>
+            <a:picLocks noChangeAspect="1" noChangeArrowheads="1"/>
+          </p:cNvPicPr>
+          <p:nvPr/>
+        </p:nvPicPr>
+        <p:blipFill rotWithShape="1">
+          <a:blip r:embed="rId19">
+            <a:extLst>
+              <a:ext uri="{28A0092B-C50C-407E-A947-70E740481C1C}">
+                <a14:useLocalDpi xmlns:a14="http://schemas.microsoft.com/office/drawing/2010/main" val="0"/>
+              </a:ext>
+            </a:extLst>
+          </a:blip>
+          <a:srcRect l="16377" t="22082" r="13186" b="19595"/>
+          <a:stretch>
+            <a:fillRect/>
+          </a:stretch>
+        </p:blipFill>
+        <p:spPr bwMode="auto">
+          <a:xfrm>
+            <a:off x="324266" y="3667302"/>
+            <a:ext cx="918453" cy="468000"/>
+          </a:xfrm>
+          <a:prstGeom prst="rect">
+            <a:avLst/>
+          </a:prstGeom>
+          <a:noFill/>
+          <a:extLst>
+            <a:ext uri="{909E8E84-426E-40DD-AFC4-6F175D3DCCD1}">
+              <a14:hiddenFill xmlns:a14="http://schemas.microsoft.com/office/drawing/2010/main">
+                <a:solidFill>
+                  <a:srgbClr val="FFFFFF"/>
+                </a:solidFill>
+              </a14:hiddenFill>
+            </a:ext>
+          </a:extLst>
+        </p:spPr>
+      </p:pic>
     </p:spTree>
     <p:extLst>
       <p:ext uri="{BB962C8B-B14F-4D97-AF65-F5344CB8AC3E}">

</xml_diff>